<commit_message>
pptx: NCAR Blue section dividers and HTML-style tables (#23)
</commit_message>
<xml_diff>
--- a/docs/common/branding/ncar/template.pptx
+++ b/docs/common/branding/ncar/template.pptx
@@ -1895,8 +1895,16 @@
 </file>
 
 <file path=ppt/slideLayouts/slideLayout5.xml><?xml version="1.0" encoding="utf-8"?>
-<p:sldLayout xmlns:a="http://schemas.openxmlformats.org/drawingml/2006/main" xmlns:r="http://schemas.openxmlformats.org/officeDocument/2006/relationships" xmlns:p="http://schemas.openxmlformats.org/presentationml/2006/main" type="secHead" preserve="1">
+<p:sldLayout xmlns:a="http://schemas.openxmlformats.org/drawingml/2006/main" xmlns:r="http://schemas.openxmlformats.org/officeDocument/2006/relationships" xmlns:p="http://schemas.openxmlformats.org/presentationml/2006/main" type="secHead" preserve="1" showMasterSp="0">
   <p:cSld name="Section Header">
+    <p:bg>
+      <p:bgPr>
+        <a:solidFill>
+          <a:schemeClr val="tx2"/>
+        </a:solidFill>
+        <a:effectLst/>
+      </p:bgPr>
+    </p:bg>
     <p:spTree>
       <p:nvGrpSpPr>
         <p:cNvPr id="1" name=""/>
@@ -1913,6 +1921,277 @@
       </p:grpSpPr>
       <p:sp>
         <p:nvSpPr>
+          <p:cNvPr id="6" name="Wave band 1"/>
+          <p:cNvSpPr/>
+          <p:nvPr userDrawn="1"/>
+        </p:nvSpPr>
+        <p:spPr>
+          <a:xfrm>
+            <a:off x="0" y="0"/>
+            <a:ext cx="12192000" cy="6858000"/>
+          </a:xfrm>
+          <a:custGeom>
+            <a:avLst/>
+            <a:gdLst/>
+            <a:ahLst/>
+            <a:cxnLst/>
+            <a:rect l="0" t="0" r="r" b="b"/>
+            <a:pathLst>
+              <a:path w="16000" h="9000" stroke="0">
+                <a:moveTo>
+                  <a:pt x="11939" y="0"/>
+                </a:moveTo>
+                <a:cubicBezTo>
+                  <a:pt x="12299" y="1778"/>
+                  <a:pt x="13869" y="4468"/>
+                  <a:pt x="13869" y="6089"/>
+                </a:cubicBezTo>
+                <a:cubicBezTo>
+                  <a:pt x="13869" y="7867"/>
+                  <a:pt x="13370" y="8713"/>
+                  <a:pt x="13238" y="9000"/>
+                </a:cubicBezTo>
+                <a:lnTo>
+                  <a:pt x="13760" y="9000"/>
+                </a:lnTo>
+                <a:cubicBezTo>
+                  <a:pt x="14218" y="8249"/>
+                  <a:pt x="14672" y="7476"/>
+                  <a:pt x="14672" y="5781"/>
+                </a:cubicBezTo>
+                <a:cubicBezTo>
+                  <a:pt x="14672" y="4272"/>
+                  <a:pt x="12803" y="1425"/>
+                  <a:pt x="12381" y="0"/>
+                </a:cubicBezTo>
+                <a:close/>
+              </a:path>
+            </a:pathLst>
+          </a:custGeom>
+          <a:solidFill>
+            <a:schemeClr val="accent1">
+              <a:alpha val="18000"/>
+            </a:schemeClr>
+          </a:solidFill>
+          <a:ln>
+            <a:noFill/>
+          </a:ln>
+        </p:spPr>
+      </p:sp>
+      <p:sp>
+        <p:nvSpPr>
+          <p:cNvPr id="7" name="Wave band 2"/>
+          <p:cNvSpPr/>
+          <p:nvPr userDrawn="1"/>
+        </p:nvSpPr>
+        <p:spPr>
+          <a:xfrm>
+            <a:off x="0" y="0"/>
+            <a:ext cx="12192000" cy="6858000"/>
+          </a:xfrm>
+          <a:custGeom>
+            <a:avLst/>
+            <a:gdLst/>
+            <a:ahLst/>
+            <a:cxnLst/>
+            <a:rect l="0" t="0" r="r" b="b"/>
+            <a:pathLst>
+              <a:path w="16000" h="9000" stroke="0">
+                <a:moveTo>
+                  <a:pt x="12381" y="0"/>
+                </a:moveTo>
+                <a:cubicBezTo>
+                  <a:pt x="12803" y="1425"/>
+                  <a:pt x="14672" y="4272"/>
+                  <a:pt x="14672" y="5781"/>
+                </a:cubicBezTo>
+                <a:cubicBezTo>
+                  <a:pt x="14672" y="7476"/>
+                  <a:pt x="14218" y="8249"/>
+                  <a:pt x="13760" y="9000"/>
+                </a:cubicBezTo>
+                <a:lnTo>
+                  <a:pt x="14272" y="9000"/>
+                </a:lnTo>
+                <a:cubicBezTo>
+                  <a:pt x="14782" y="8320"/>
+                  <a:pt x="15477" y="7418"/>
+                  <a:pt x="15477" y="5564"/>
+                </a:cubicBezTo>
+                <a:cubicBezTo>
+                  <a:pt x="15477" y="3969"/>
+                  <a:pt x="13379" y="1243"/>
+                  <a:pt x="12843" y="0"/>
+                </a:cubicBezTo>
+                <a:close/>
+              </a:path>
+            </a:pathLst>
+          </a:custGeom>
+          <a:solidFill>
+            <a:schemeClr val="accent1">
+              <a:alpha val="10000"/>
+            </a:schemeClr>
+          </a:solidFill>
+          <a:ln>
+            <a:noFill/>
+          </a:ln>
+        </p:spPr>
+      </p:sp>
+      <p:sp>
+        <p:nvSpPr>
+          <p:cNvPr id="8" name="Wave line 1"/>
+          <p:cNvSpPr/>
+          <p:nvPr userDrawn="1"/>
+        </p:nvSpPr>
+        <p:spPr>
+          <a:xfrm>
+            <a:off x="0" y="0"/>
+            <a:ext cx="12192000" cy="6858000"/>
+          </a:xfrm>
+          <a:custGeom>
+            <a:avLst/>
+            <a:gdLst/>
+            <a:ahLst/>
+            <a:cxnLst/>
+            <a:rect l="0" t="0" r="r" b="b"/>
+            <a:pathLst>
+              <a:path w="16000" h="9000" fill="none">
+                <a:moveTo>
+                  <a:pt x="11939" y="0"/>
+                </a:moveTo>
+                <a:cubicBezTo>
+                  <a:pt x="12299" y="1778"/>
+                  <a:pt x="13869" y="4468"/>
+                  <a:pt x="13869" y="6089"/>
+                </a:cubicBezTo>
+                <a:cubicBezTo>
+                  <a:pt x="13869" y="7867"/>
+                  <a:pt x="13370" y="8713"/>
+                  <a:pt x="13238" y="9000"/>
+                </a:cubicBezTo>
+              </a:path>
+            </a:pathLst>
+          </a:custGeom>
+          <a:noFill/>
+          <a:ln w="18288">
+            <a:solidFill>
+              <a:schemeClr val="accent1"/>
+            </a:solidFill>
+          </a:ln>
+        </p:spPr>
+      </p:sp>
+      <p:sp>
+        <p:nvSpPr>
+          <p:cNvPr id="9" name="Wave line 2"/>
+          <p:cNvSpPr/>
+          <p:nvPr userDrawn="1"/>
+        </p:nvSpPr>
+        <p:spPr>
+          <a:xfrm>
+            <a:off x="0" y="0"/>
+            <a:ext cx="12192000" cy="6858000"/>
+          </a:xfrm>
+          <a:custGeom>
+            <a:avLst/>
+            <a:gdLst/>
+            <a:ahLst/>
+            <a:cxnLst/>
+            <a:rect l="0" t="0" r="r" b="b"/>
+            <a:pathLst>
+              <a:path w="16000" h="9000" fill="none">
+                <a:moveTo>
+                  <a:pt x="12381" y="0"/>
+                </a:moveTo>
+                <a:cubicBezTo>
+                  <a:pt x="12803" y="1425"/>
+                  <a:pt x="14672" y="4272"/>
+                  <a:pt x="14672" y="5781"/>
+                </a:cubicBezTo>
+                <a:cubicBezTo>
+                  <a:pt x="14672" y="7476"/>
+                  <a:pt x="14218" y="8249"/>
+                  <a:pt x="13760" y="9000"/>
+                </a:cubicBezTo>
+              </a:path>
+            </a:pathLst>
+          </a:custGeom>
+          <a:noFill/>
+          <a:ln w="18288">
+            <a:solidFill>
+              <a:schemeClr val="accent1"/>
+            </a:solidFill>
+          </a:ln>
+        </p:spPr>
+      </p:sp>
+      <p:sp>
+        <p:nvSpPr>
+          <p:cNvPr id="10" name="Wave line 3"/>
+          <p:cNvSpPr/>
+          <p:nvPr userDrawn="1"/>
+        </p:nvSpPr>
+        <p:spPr>
+          <a:xfrm>
+            <a:off x="0" y="0"/>
+            <a:ext cx="12192000" cy="6858000"/>
+          </a:xfrm>
+          <a:custGeom>
+            <a:avLst/>
+            <a:gdLst/>
+            <a:ahLst/>
+            <a:cxnLst/>
+            <a:rect l="0" t="0" r="r" b="b"/>
+            <a:pathLst>
+              <a:path w="16000" h="9000" fill="none">
+                <a:moveTo>
+                  <a:pt x="12843" y="0"/>
+                </a:moveTo>
+                <a:cubicBezTo>
+                  <a:pt x="13379" y="1243"/>
+                  <a:pt x="15477" y="3969"/>
+                  <a:pt x="15477" y="5564"/>
+                </a:cubicBezTo>
+                <a:cubicBezTo>
+                  <a:pt x="15477" y="7418"/>
+                  <a:pt x="14782" y="8320"/>
+                  <a:pt x="14272" y="9000"/>
+                </a:cubicBezTo>
+              </a:path>
+            </a:pathLst>
+          </a:custGeom>
+          <a:noFill/>
+          <a:ln w="18288">
+            <a:solidFill>
+              <a:schemeClr val="accent1"/>
+            </a:solidFill>
+          </a:ln>
+        </p:spPr>
+      </p:sp>
+      <p:pic>
+        <p:nvPicPr>
+          <p:cNvPr id="4" name="NSF NCAR logo" descr="NSF NCAR"/>
+          <p:cNvPicPr>
+            <a:picLocks noChangeAspect="1"/>
+          </p:cNvPicPr>
+          <p:nvPr userDrawn="1"/>
+        </p:nvPicPr>
+        <p:blipFill>
+          <a:blip r:embed="rId2"/>
+          <a:stretch>
+            <a:fillRect/>
+          </a:stretch>
+        </p:blipFill>
+        <p:spPr>
+          <a:xfrm>
+            <a:off x="731520" y="548640"/>
+            <a:ext cx="1691640" cy="441960"/>
+          </a:xfrm>
+          <a:prstGeom prst="rect">
+            <a:avLst/>
+          </a:prstGeom>
+        </p:spPr>
+      </p:pic>
+      <p:sp>
+        <p:nvSpPr>
           <p:cNvPr id="2" name="Title 1"/>
           <p:cNvSpPr>
             <a:spLocks noGrp="1"/>
@@ -1923,29 +2202,34 @@
         </p:nvSpPr>
         <p:spPr>
           <a:xfrm>
-            <a:off x="609600" y="2743200"/>
-            <a:ext cx="10972800" cy="1371600"/>
-          </a:xfrm>
-          <a:prstGeom prst="rect">
-            <a:avLst/>
-          </a:prstGeom>
-        </p:spPr>
-        <p:txBody>
-          <a:bodyPr anchor="t"/>
+            <a:off x="731520" y="3048000"/>
+            <a:ext cx="7559040" cy="838200"/>
+          </a:xfrm>
+          <a:prstGeom prst="rect">
+            <a:avLst/>
+          </a:prstGeom>
+        </p:spPr>
+        <p:txBody>
+          <a:bodyPr lIns="0" tIns="0" rIns="0" bIns="0" anchor="t">
+            <a:normAutofit/>
+          </a:bodyPr>
           <a:lstStyle>
             <a:lvl1pPr algn="l">
-              <a:defRPr sz="6000" b="1" cap="small" baseline="0">
-                <a:solidFill>
-                  <a:schemeClr val="tx1"/>
-                </a:solidFill>
-                <a:latin typeface="Poppins" pitchFamily="2" charset="77"/>
+              <a:lnSpc>
+                <a:spcPct val="90000"/>
+              </a:lnSpc>
+              <a:defRPr sz="4400" b="1" cap="none" baseline="0">
+                <a:solidFill>
+                  <a:schemeClr val="bg1"/>
+                </a:solidFill>
+                <a:latin typeface="+mj-lt"/>
               </a:defRPr>
             </a:lvl1pPr>
           </a:lstStyle>
           <a:p>
             <a:r>
-              <a:rPr lang="en-US" dirty="0"/>
-              <a:t>Click to edit Master title style</a:t>
+              <a:rPr lang="en-US"/>
+              <a:t>Section title</a:t>
             </a:r>
           </a:p>
         </p:txBody>
@@ -1962,128 +2246,42 @@
         </p:nvSpPr>
         <p:spPr>
           <a:xfrm>
-            <a:off x="609600" y="4731026"/>
-            <a:ext cx="10972800" cy="1268232"/>
-          </a:xfrm>
-          <a:prstGeom prst="rect">
-            <a:avLst/>
-          </a:prstGeom>
-        </p:spPr>
-        <p:txBody>
-          <a:bodyPr anchor="b"/>
+            <a:off x="731520" y="3962400"/>
+            <a:ext cx="7315200" cy="914400"/>
+          </a:xfrm>
+          <a:prstGeom prst="rect">
+            <a:avLst/>
+          </a:prstGeom>
+        </p:spPr>
+        <p:txBody>
+          <a:bodyPr lIns="0" tIns="0" rIns="0" bIns="0" anchor="t">
+            <a:normAutofit/>
+          </a:bodyPr>
           <a:lstStyle>
             <a:lvl1pPr marL="0" indent="0">
-              <a:buNone/>
-              <a:defRPr sz="2000">
-                <a:solidFill>
-                  <a:schemeClr val="tx1">
-                    <a:tint val="75000"/>
-                  </a:schemeClr>
+              <a:spcBef>
+                <a:spcPts val="0"/>
+              </a:spcBef>
+              <a:buNone/>
+              <a:defRPr sz="1800" b="0">
+                <a:solidFill>
+                  <a:schemeClr val="bg1"/>
                 </a:solidFill>
               </a:defRPr>
             </a:lvl1pPr>
-            <a:lvl2pPr marL="457189" indent="0">
-              <a:buNone/>
-              <a:defRPr sz="1800">
-                <a:solidFill>
-                  <a:schemeClr val="tx1">
-                    <a:tint val="75000"/>
-                  </a:schemeClr>
-                </a:solidFill>
-              </a:defRPr>
-            </a:lvl2pPr>
-            <a:lvl3pPr marL="914377" indent="0">
-              <a:buNone/>
-              <a:defRPr sz="1600">
-                <a:solidFill>
-                  <a:schemeClr val="tx1">
-                    <a:tint val="75000"/>
-                  </a:schemeClr>
-                </a:solidFill>
-              </a:defRPr>
-            </a:lvl3pPr>
-            <a:lvl4pPr marL="1371566" indent="0">
-              <a:buNone/>
-              <a:defRPr sz="1400">
-                <a:solidFill>
-                  <a:schemeClr val="tx1">
-                    <a:tint val="75000"/>
-                  </a:schemeClr>
-                </a:solidFill>
-              </a:defRPr>
-            </a:lvl4pPr>
-            <a:lvl5pPr marL="1828754" indent="0">
-              <a:buNone/>
-              <a:defRPr sz="1400">
-                <a:solidFill>
-                  <a:schemeClr val="tx1">
-                    <a:tint val="75000"/>
-                  </a:schemeClr>
-                </a:solidFill>
-              </a:defRPr>
-            </a:lvl5pPr>
-            <a:lvl6pPr marL="2285943" indent="0">
-              <a:buNone/>
-              <a:defRPr sz="1400">
-                <a:solidFill>
-                  <a:schemeClr val="tx1">
-                    <a:tint val="75000"/>
-                  </a:schemeClr>
-                </a:solidFill>
-              </a:defRPr>
-            </a:lvl6pPr>
-            <a:lvl7pPr marL="2743131" indent="0">
-              <a:buNone/>
-              <a:defRPr sz="1400">
-                <a:solidFill>
-                  <a:schemeClr val="tx1">
-                    <a:tint val="75000"/>
-                  </a:schemeClr>
-                </a:solidFill>
-              </a:defRPr>
-            </a:lvl7pPr>
-            <a:lvl8pPr marL="3200320" indent="0">
-              <a:buNone/>
-              <a:defRPr sz="1400">
-                <a:solidFill>
-                  <a:schemeClr val="tx1">
-                    <a:tint val="75000"/>
-                  </a:schemeClr>
-                </a:solidFill>
-              </a:defRPr>
-            </a:lvl8pPr>
-            <a:lvl9pPr marL="3657509" indent="0">
-              <a:buNone/>
-              <a:defRPr sz="1400">
-                <a:solidFill>
-                  <a:schemeClr val="tx1">
-                    <a:tint val="75000"/>
-                  </a:schemeClr>
-                </a:solidFill>
-              </a:defRPr>
-            </a:lvl9pPr>
           </a:lstStyle>
           <a:p>
-            <a:pPr lvl="0"/>
-            <a:r>
-              <a:rPr lang="en-US" dirty="0"/>
-              <a:t>Click to edit Master text styles</a:t>
-            </a:r>
-          </a:p>
-        </p:txBody>
-      </p:sp>
-      <p:sp>
-        <p:nvSpPr>
-          <p:cNvPr id="4" name="Slide Number Placeholder 5">
-            <a:extLst>
-              <a:ext uri="{FF2B5EF4-FFF2-40B4-BE49-F238E27FC236}">
-                <a16:creationId xmlns:a16="http://schemas.microsoft.com/office/drawing/2014/main" id="{FC0B6802-E68E-6161-D5A8-87793D9776EB}"/>
-              </a:ext>
-            </a:extLst>
-          </p:cNvPr>
-          <p:cNvSpPr txBox="1">
-            <a:spLocks/>
-          </p:cNvSpPr>
+            <a:r>
+              <a:rPr lang="en-US"/>
+              <a:t>Subtitle</a:t>
+            </a:r>
+          </a:p>
+        </p:txBody>
+      </p:sp>
+      <p:sp>
+        <p:nvSpPr>
+          <p:cNvPr id="5" name="Slide Number"/>
+          <p:cNvSpPr txBox="1"/>
           <p:nvPr userDrawn="1"/>
         </p:nvSpPr>
         <p:spPr>
@@ -2096,207 +2294,23 @@
           </a:prstGeom>
         </p:spPr>
         <p:txBody>
-          <a:bodyPr vert="horz" lIns="91440" tIns="45720" rIns="91440" bIns="45720" rtlCol="0" anchor="ctr"/>
-          <a:lstStyle>
-            <a:defPPr>
-              <a:defRPr lang="en-US"/>
-            </a:defPPr>
-            <a:lvl1pPr marL="0" algn="ctr" defTabSz="609585" rtl="0" eaLnBrk="1" latinLnBrk="0" hangingPunct="1">
-              <a:defRPr sz="1200" kern="1200" baseline="0">
-                <a:solidFill>
-                  <a:schemeClr val="tx1"/>
+          <a:bodyPr anchor="ctr"/>
+          <a:lstStyle/>
+          <a:p>
+            <a:pPr algn="ctr"/>
+            <a:fld id="{C5EF2332-01BF-834F-8236-50238282D533}" type="slidenum">
+              <a:rPr lang="en-US" sz="1200">
+                <a:solidFill>
+                  <a:schemeClr val="bg1"/>
                 </a:solidFill>
                 <a:latin typeface="+mn-lt"/>
-                <a:ea typeface="+mn-ea"/>
-                <a:cs typeface="+mn-cs"/>
-              </a:defRPr>
-            </a:lvl1pPr>
-            <a:lvl2pPr marL="609585" algn="l" defTabSz="609585" rtl="0" eaLnBrk="1" latinLnBrk="0" hangingPunct="1">
-              <a:defRPr sz="2400" kern="1200">
-                <a:solidFill>
-                  <a:schemeClr val="tx1"/>
-                </a:solidFill>
-                <a:latin typeface="+mn-lt"/>
-                <a:ea typeface="+mn-ea"/>
-                <a:cs typeface="+mn-cs"/>
-              </a:defRPr>
-            </a:lvl2pPr>
-            <a:lvl3pPr marL="1219170" algn="l" defTabSz="609585" rtl="0" eaLnBrk="1" latinLnBrk="0" hangingPunct="1">
-              <a:defRPr sz="2400" kern="1200">
-                <a:solidFill>
-                  <a:schemeClr val="tx1"/>
-                </a:solidFill>
-                <a:latin typeface="+mn-lt"/>
-                <a:ea typeface="+mn-ea"/>
-                <a:cs typeface="+mn-cs"/>
-              </a:defRPr>
-            </a:lvl3pPr>
-            <a:lvl4pPr marL="1828754" algn="l" defTabSz="609585" rtl="0" eaLnBrk="1" latinLnBrk="0" hangingPunct="1">
-              <a:defRPr sz="2400" kern="1200">
-                <a:solidFill>
-                  <a:schemeClr val="tx1"/>
-                </a:solidFill>
-                <a:latin typeface="+mn-lt"/>
-                <a:ea typeface="+mn-ea"/>
-                <a:cs typeface="+mn-cs"/>
-              </a:defRPr>
-            </a:lvl4pPr>
-            <a:lvl5pPr marL="2438339" algn="l" defTabSz="609585" rtl="0" eaLnBrk="1" latinLnBrk="0" hangingPunct="1">
-              <a:defRPr sz="2400" kern="1200">
-                <a:solidFill>
-                  <a:schemeClr val="tx1"/>
-                </a:solidFill>
-                <a:latin typeface="+mn-lt"/>
-                <a:ea typeface="+mn-ea"/>
-                <a:cs typeface="+mn-cs"/>
-              </a:defRPr>
-            </a:lvl5pPr>
-            <a:lvl6pPr marL="3047924" algn="l" defTabSz="609585" rtl="0" eaLnBrk="1" latinLnBrk="0" hangingPunct="1">
-              <a:defRPr sz="2400" kern="1200">
-                <a:solidFill>
-                  <a:schemeClr val="tx1"/>
-                </a:solidFill>
-                <a:latin typeface="+mn-lt"/>
-                <a:ea typeface="+mn-ea"/>
-                <a:cs typeface="+mn-cs"/>
-              </a:defRPr>
-            </a:lvl6pPr>
-            <a:lvl7pPr marL="3657509" algn="l" defTabSz="609585" rtl="0" eaLnBrk="1" latinLnBrk="0" hangingPunct="1">
-              <a:defRPr sz="2400" kern="1200">
-                <a:solidFill>
-                  <a:schemeClr val="tx1"/>
-                </a:solidFill>
-                <a:latin typeface="+mn-lt"/>
-                <a:ea typeface="+mn-ea"/>
-                <a:cs typeface="+mn-cs"/>
-              </a:defRPr>
-            </a:lvl7pPr>
-            <a:lvl8pPr marL="4267093" algn="l" defTabSz="609585" rtl="0" eaLnBrk="1" latinLnBrk="0" hangingPunct="1">
-              <a:defRPr sz="2400" kern="1200">
-                <a:solidFill>
-                  <a:schemeClr val="tx1"/>
-                </a:solidFill>
-                <a:latin typeface="+mn-lt"/>
-                <a:ea typeface="+mn-ea"/>
-                <a:cs typeface="+mn-cs"/>
-              </a:defRPr>
-            </a:lvl8pPr>
-            <a:lvl9pPr marL="4876678" algn="l" defTabSz="609585" rtl="0" eaLnBrk="1" latinLnBrk="0" hangingPunct="1">
-              <a:defRPr sz="2400" kern="1200">
-                <a:solidFill>
-                  <a:schemeClr val="tx1"/>
-                </a:solidFill>
-                <a:latin typeface="+mn-lt"/>
-                <a:ea typeface="+mn-ea"/>
-                <a:cs typeface="+mn-cs"/>
-              </a:defRPr>
-            </a:lvl9pPr>
-          </a:lstStyle>
-          <a:p>
-            <a:fld id="{C5EF2332-01BF-834F-8236-50238282D533}" type="slidenum">
-              <a:rPr lang="en-US" smtClean="0"/>
-              <a:pPr/>
+              </a:rPr>
               <a:t>‹#›</a:t>
             </a:fld>
-            <a:endParaRPr lang="en-US" dirty="0"/>
-          </a:p>
-        </p:txBody>
-      </p:sp>
-      <p:sp>
-        <p:nvSpPr>
-          <p:cNvPr id="5" name="Date Placeholder 4">
-            <a:extLst>
-              <a:ext uri="{FF2B5EF4-FFF2-40B4-BE49-F238E27FC236}">
-                <a16:creationId xmlns:a16="http://schemas.microsoft.com/office/drawing/2014/main" id="{68A9EDD1-4B41-9FEA-B502-10B14890AC01}"/>
-              </a:ext>
-            </a:extLst>
-          </p:cNvPr>
-          <p:cNvSpPr>
-            <a:spLocks noGrp="1"/>
-          </p:cNvSpPr>
-          <p:nvPr>
-            <p:ph type="dt" sz="half" idx="2"/>
-          </p:nvPr>
-        </p:nvSpPr>
-        <p:spPr>
-          <a:xfrm>
-            <a:off x="10436086" y="6556499"/>
-            <a:ext cx="1374913" cy="182799"/>
-          </a:xfrm>
-          <a:prstGeom prst="rect">
-            <a:avLst/>
-          </a:prstGeom>
-        </p:spPr>
-        <p:txBody>
-          <a:bodyPr vert="horz" lIns="91440" tIns="45720" rIns="91440" bIns="45720" rtlCol="0" anchor="ctr"/>
-          <a:lstStyle>
-            <a:lvl1pPr algn="r">
-              <a:defRPr sz="1200" baseline="0">
-                <a:solidFill>
-                  <a:schemeClr val="tx1"/>
-                </a:solidFill>
-              </a:defRPr>
-            </a:lvl1pPr>
-          </a:lstStyle>
-          <a:p>
-            <a:pPr algn="r"/>
-            <a:fld id="{34459720-2A4C-D342-9515-00AC0588A96C}" type="datetimeFigureOut">
-              <a:rPr lang="en-US" smtClean="0"/>
-              <a:pPr algn="r"/>
-              <a:t>4/30/26</a:t>
-            </a:fld>
-            <a:endParaRPr lang="en-US" dirty="0"/>
-          </a:p>
-        </p:txBody>
-      </p:sp>
-      <p:sp>
-        <p:nvSpPr>
-          <p:cNvPr id="6" name="Footer Placeholder 6">
-            <a:extLst>
-              <a:ext uri="{FF2B5EF4-FFF2-40B4-BE49-F238E27FC236}">
-                <a16:creationId xmlns:a16="http://schemas.microsoft.com/office/drawing/2014/main" id="{45184FA6-E749-CC87-5ED0-206998A07D57}"/>
-              </a:ext>
-            </a:extLst>
-          </p:cNvPr>
-          <p:cNvSpPr>
-            <a:spLocks noGrp="1"/>
-          </p:cNvSpPr>
-          <p:nvPr>
-            <p:ph type="ftr" sz="quarter" idx="3"/>
-          </p:nvPr>
-        </p:nvSpPr>
-        <p:spPr>
-          <a:xfrm>
-            <a:off x="555265" y="6556499"/>
-            <a:ext cx="4114800" cy="182799"/>
-          </a:xfrm>
-          <a:prstGeom prst="rect">
-            <a:avLst/>
-          </a:prstGeom>
-        </p:spPr>
-        <p:txBody>
-          <a:bodyPr vert="horz" lIns="91440" tIns="45720" rIns="91440" bIns="45720" rtlCol="0" anchor="ctr"/>
-          <a:lstStyle>
-            <a:lvl1pPr algn="l">
-              <a:defRPr sz="1200" baseline="0">
-                <a:solidFill>
-                  <a:schemeClr val="tx1"/>
-                </a:solidFill>
-              </a:defRPr>
-            </a:lvl1pPr>
-          </a:lstStyle>
-          <a:p>
-            <a:pPr algn="l"/>
-            <a:endParaRPr lang="en-US" dirty="0"/>
           </a:p>
         </p:txBody>
       </p:sp>
     </p:spTree>
-    <p:extLst>
-      <p:ext uri="{BB962C8B-B14F-4D97-AF65-F5344CB8AC3E}">
-        <p14:creationId xmlns:p14="http://schemas.microsoft.com/office/powerpoint/2010/main" val="1073069076"/>
-      </p:ext>
-    </p:extLst>
   </p:cSld>
   <p:clrMapOvr>
     <a:masterClrMapping/>

</xml_diff>